<commit_message>
Auditoría de Consistencia, Evidencia y Preparación para Revisión Técnica del MEN (PEVN)
</commit_message>
<xml_diff>
--- a/docs/government/pdf/PEVN_PRESENTACION_INSTITUCIONAL_MEN.pptx
+++ b/docs/government/pdf/PEVN_PRESENTACION_INSTITUCIONAL_MEN.pptx
@@ -7591,7 +7591,7 @@
                         </a:defRPr>
                       </a:pPr>
                       <a:r>
-                        <a:t>Autenticación JWT y RBAC (11 Roles)</a:t>
+                        <a:t>Autenticación JWT y RBAC (9 Canónicos / 11 BD)</a:t>
                       </a:r>
                     </a:p>
                   </a:txBody>
@@ -7637,7 +7637,7 @@
                         </a:defRPr>
                       </a:pPr>
                       <a:r>
-                        <a:t>backend/app/core/security.py</a:t>
+                        <a:t>backend/app/core/security/interfaces.py</a:t>
                       </a:r>
                     </a:p>
                     <a:p>
@@ -7791,7 +7791,7 @@
                         </a:defRPr>
                       </a:pPr>
                       <a:r>
-                        <a:t>Gobernanza Territorial DANE/DIVIPOLA</a:t>
+                        <a:t>Catálogo Territorial y DUE 2024 (Precarga)</a:t>
                       </a:r>
                     </a:p>
                   </a:txBody>
@@ -7809,12 +7809,12 @@
                       <a:pPr>
                         <a:defRPr sz="1000" b="1">
                           <a:solidFill>
-                            <a:srgbClr val="10955D"/>
+                            <a:srgbClr val="6D28D9"/>
                           </a:solidFill>
                         </a:defRPr>
                       </a:pPr>
                       <a:r>
-                        <a:t>IMPLEMENTADO</a:t>
+                        <a:t>CATÁLOGO PRECARGADO</a:t>
                       </a:r>
                     </a:p>
                   </a:txBody>
@@ -7837,7 +7837,19 @@
                         </a:defRPr>
                       </a:pPr>
                       <a:r>
-                        <a:t>Catálogo CSV / backend/app/models/territorial.py</a:t>
+                        <a:t>SODA cfw5-qzt5 / 96t6-cfw4</a:t>
+                      </a:r>
+                    </a:p>
+                    <a:p>
+                      <a:pPr>
+                        <a:defRPr sz="1000">
+                          <a:solidFill>
+                            <a:srgbClr val="1E293B"/>
+                          </a:solidFill>
+                        </a:defRPr>
+                      </a:pPr>
+                      <a:r>
+                        <a:t>official_institution_catalog</a:t>
                       </a:r>
                     </a:p>
                   </a:txBody>
@@ -7860,7 +7872,7 @@
                         </a:defRPr>
                       </a:pPr>
                       <a:r>
-                        <a:t>Sí (Catálogo precargado)</a:t>
+                        <a:t>Sí (18.031 EE / 51.521 Sedes ref.)</a:t>
                       </a:r>
                     </a:p>
                   </a:txBody>
@@ -8733,6 +8745,30 @@
                   <a:srgbClr val="0F2942"/>
                 </a:solidFill>
               </a:rPr>
+              <a:t>690 Pruebas Restantes No Ejecutadas:</a:t>
+            </a:r>
+            <a:r>
+              <a:rPr b="0"/>
+              <a:t> Excluidas deliberadamente de este ciclo acotado para preservar aislamiento y estabilidad.</a:t>
+            </a:r>
+          </a:p>
+          <a:p>
+            <a:pPr>
+              <a:spcAft>
+                <a:spcPts val="600"/>
+              </a:spcAft>
+              <a:defRPr sz="1050">
+                <a:solidFill>
+                  <a:srgbClr val="1E293B"/>
+                </a:solidFill>
+              </a:defRPr>
+            </a:pPr>
+            <a:r>
+              <a:rPr b="1">
+                <a:solidFill>
+                  <a:srgbClr val="0F2942"/>
+                </a:solidFill>
+              </a:rPr>
               <a:t>Frontend:</a:t>
             </a:r>
             <a:r>
@@ -11403,11 +11439,11 @@
                   <a:srgbClr val="0F2942"/>
                 </a:solidFill>
               </a:rPr>
-              <a:t>Estándares DANE:</a:t>
+              <a:t>Modelo y Estándares:</a:t>
             </a:r>
             <a:r>
               <a:rPr b="0"/>
-              <a:t> 1,122 municipios (DIVIPOLA) y catálogo de 18,031 colegios y 51,521 sedes precargadas.</a:t>
+              <a:t> Jerarquía canónica de 9 roles (11 en BD). Catálogo DANE precargado (18,031 colegios, 51,521 sedes; no implica adopción).</a:t>
             </a:r>
           </a:p>
         </p:txBody>
@@ -14853,7 +14889,7 @@
               </a:defRPr>
             </a:pPr>
             <a:r>
-              <a:t>Usuarios, Jerarquía RBAC (11 Roles) y Autoridad Delegada</a:t>
+              <a:t>Jerarquía Canónica RBAC (9 Roles) y Modelo de Autoridad</a:t>
             </a:r>
           </a:p>
         </p:txBody>
@@ -15051,7 +15087,7 @@
               </a:defRPr>
             </a:pPr>
             <a:r>
-              <a:t>Catálogo Canónico de Roles Tipados en Base de Datos</a:t>
+              <a:t>Catálogo Canónico de 9 Roles (11 Identificadores en BD)</a:t>
             </a:r>
           </a:p>
           <a:p>
@@ -15075,7 +15111,7 @@
             </a:r>
             <a:r>
               <a:rPr b="0"/>
-              <a:t> Gobernanza global de plataforma y Secretarías.</a:t>
+              <a:t> Operador técnico de plataforma e infraestructura.</a:t>
             </a:r>
           </a:p>
           <a:p>
@@ -15099,7 +15135,7 @@
             </a:r>
             <a:r>
               <a:rPr b="0"/>
-              <a:t> Administrador Nacional MEN y auditoría central.</a:t>
+              <a:t> Administrador Nacional MEN y gobierno general.</a:t>
             </a:r>
           </a:p>
           <a:p>
@@ -15167,35 +15203,35 @@
                   <a:srgbClr val="0F2942"/>
                 </a:solidFill>
               </a:rPr>
-              <a:t>[60] rector / institution_admin:</a:t>
+              <a:t>[60] rector:</a:t>
             </a:r>
             <a:r>
               <a:rPr b="0"/>
-              <a:t> Máxima autoridad directiva del tenant.</a:t>
-            </a:r>
-          </a:p>
-          <a:p>
-            <a:pPr>
-              <a:spcAft>
-                <a:spcPts val="600"/>
-              </a:spcAft>
-              <a:defRPr sz="1050">
-                <a:solidFill>
-                  <a:srgbClr val="1E293B"/>
-                </a:solidFill>
-              </a:defRPr>
-            </a:pPr>
-            <a:r>
-              <a:rPr b="1">
-                <a:solidFill>
-                  <a:srgbClr val="0F2942"/>
-                </a:solidFill>
-              </a:rPr>
-              <a:t>[50] coordinator / academic_coordinator:</a:t>
+              <a:t> Rector / Director Institucional (Alias técnico: institution_admin).</a:t>
+            </a:r>
+          </a:p>
+          <a:p>
+            <a:pPr>
+              <a:spcAft>
+                <a:spcPts val="600"/>
+              </a:spcAft>
+              <a:defRPr sz="1050">
+                <a:solidFill>
+                  <a:srgbClr val="1E293B"/>
+                </a:solidFill>
+              </a:defRPr>
+            </a:pPr>
+            <a:r>
+              <a:rPr b="1">
+                <a:solidFill>
+                  <a:srgbClr val="0F2942"/>
+                </a:solidFill>
+              </a:rPr>
+              <a:t>[50] coordinator:</a:t>
             </a:r>
             <a:r>
               <a:rPr b="0"/>
-              <a:t> Coordinación académica/sede.</a:t>
+              <a:t> Coordinador Académico / Sede (Alias técnico: academic_coordinator).</a:t>
             </a:r>
           </a:p>
           <a:p>
@@ -15239,11 +15275,35 @@
                   <a:srgbClr val="0F2942"/>
                 </a:solidFill>
               </a:rPr>
-              <a:t>[10] student / guardian:</a:t>
+              <a:t>[10] student:</a:t>
             </a:r>
             <a:r>
               <a:rPr b="0"/>
-              <a:t> Estudiante matriculado y acudiente legal.</a:t>
+              <a:t> Estudiante matriculado (SIMAT).</a:t>
+            </a:r>
+          </a:p>
+          <a:p>
+            <a:pPr>
+              <a:spcAft>
+                <a:spcPts val="600"/>
+              </a:spcAft>
+              <a:defRPr sz="1050">
+                <a:solidFill>
+                  <a:srgbClr val="1E293B"/>
+                </a:solidFill>
+              </a:defRPr>
+            </a:pPr>
+            <a:r>
+              <a:rPr b="1">
+                <a:solidFill>
+                  <a:srgbClr val="0F2942"/>
+                </a:solidFill>
+              </a:rPr>
+              <a:t>[10] guardian:</a:t>
+            </a:r>
+            <a:r>
+              <a:rPr b="0"/>
+              <a:t> Acudiente / Tutor legal civil.</a:t>
             </a:r>
           </a:p>
         </p:txBody>
@@ -15346,73 +15406,86 @@
                   <a:srgbClr val="0F2942"/>
                 </a:solidFill>
               </a:rPr>
-              <a:t>Prevención de Escalamiento Vertical:</a:t>
-            </a:r>
-            <a:r>
-              <a:rPr b="0"/>
-              <a:t> Ningún usuario puede asignar un rol de nivel igual o superior al suyo en la jerarquía.</a:t>
-            </a:r>
-          </a:p>
-          <a:p>
-            <a:pPr>
-              <a:spcAft>
-                <a:spcPts val="600"/>
-              </a:spcAft>
-              <a:defRPr sz="1050">
-                <a:solidFill>
-                  <a:srgbClr val="1E293B"/>
-                </a:solidFill>
-              </a:defRPr>
-            </a:pPr>
-            <a:r>
-              <a:rPr b="1">
-                <a:solidFill>
-                  <a:srgbClr val="0F2942"/>
-                </a:solidFill>
-              </a:rPr>
-              <a:t>Aislamiento de Ámbito:</a:t>
-            </a:r>
-            <a:r>
-              <a:rPr b="0"/>
-              <a:t> Los administradores territoriales solo operan sobre municipios o instituciones de su jurisdicción DANE.</a:t>
-            </a:r>
-          </a:p>
-          <a:p>
-            <a:pPr>
-              <a:spcAft>
-                <a:spcPts val="600"/>
-              </a:spcAft>
-              <a:defRPr sz="1050">
-                <a:solidFill>
-                  <a:srgbClr val="1E293B"/>
-                </a:solidFill>
-              </a:defRPr>
-            </a:pPr>
-            <a:r>
-              <a:rPr b="1">
-                <a:solidFill>
-                  <a:srgbClr val="0F2942"/>
-                </a:solidFill>
-              </a:rPr>
-              <a:t>Excepción Canónica de Coordinador:</a:t>
+              <a:t>Cadena Canónica Aprobada:</a:t>
             </a:r>
             <a:r>
               <a:rPr b="0"/>
               <a:t>
-Por regla general, los coordinadores no crean usuarios. Sin embargo, en la operación escolar colombiana el Rector delega la matrícula y asignación docente.
-PEVN soporta una </a:t>
-            </a:r>
-            <a:r>
-              <a:rPr b="1">
-                <a:solidFill>
-                  <a:srgbClr val="0F2942"/>
-                </a:solidFill>
-              </a:rPr>
-              <a:t>política controlada por el Rector</a:t>
+SUPERADMIN → NATIONAL_ADMIN → DEPARTMENT_ADMIN → MUNICIPALITY_ADMIN → RECTOR → COORDINATOR → TEACHER / STUDENT → GUARDIAN.</a:t>
+            </a:r>
+          </a:p>
+          <a:p>
+            <a:pPr>
+              <a:spcAft>
+                <a:spcPts val="600"/>
+              </a:spcAft>
+              <a:defRPr sz="1050">
+                <a:solidFill>
+                  <a:srgbClr val="1E293B"/>
+                </a:solidFill>
+              </a:defRPr>
+            </a:pPr>
+            <a:r>
+              <a:rPr b="1">
+                <a:solidFill>
+                  <a:srgbClr val="0F2942"/>
+                </a:solidFill>
+              </a:rPr>
+              <a:t>Aislamiento Territorial Forzado:</a:t>
             </a:r>
             <a:r>
               <a:rPr b="0"/>
-              <a:t> (`coordinator_delegated_provisioning_enabled`): cuando está activa, el coordinador crea docentes y matricula estudiantes en su sede; si el rector la desactiva, la API bloquea la acción inmediatamente.</a:t>
+              <a:t> Ninguna autoridad puede cruzar fronteras departamentales o municipales DANE.</a:t>
+            </a:r>
+          </a:p>
+          <a:p>
+            <a:pPr>
+              <a:spcAft>
+                <a:spcPts val="600"/>
+              </a:spcAft>
+              <a:defRPr sz="1050">
+                <a:solidFill>
+                  <a:srgbClr val="1E293B"/>
+                </a:solidFill>
+              </a:defRPr>
+            </a:pPr>
+            <a:r>
+              <a:rPr b="1">
+                <a:solidFill>
+                  <a:srgbClr val="0F2942"/>
+                </a:solidFill>
+              </a:rPr>
+              <a:t>Excepción Canónica de Coordinador:</a:t>
+            </a:r>
+            <a:r>
+              <a:rPr b="0"/>
+              <a:t> Por regla general, los coordinadores no crean usuarios. No obstante, mediante la directiva institucional persistida (`coordinator_delegated_provisioning_enabled`):
+• </a:t>
+            </a:r>
+            <a:r>
+              <a:rPr b="1">
+                <a:solidFill>
+                  <a:srgbClr val="0F2942"/>
+                </a:solidFill>
+              </a:rPr>
+              <a:t>Si está inhabilitada (Default):</a:t>
+            </a:r>
+            <a:r>
+              <a:rPr b="0"/>
+              <a:t> Creación bloqueada (HTTP 403 `COORDINATOR_DELEGATION_DISABLED`).
+• </a:t>
+            </a:r>
+            <a:r>
+              <a:rPr b="1">
+                <a:solidFill>
+                  <a:srgbClr val="0F2942"/>
+                </a:solidFill>
+              </a:rPr>
+              <a:t>Si el Rector la habilita:</a:t>
+            </a:r>
+            <a:r>
+              <a:rPr b="0"/>
+              <a:t> El coordinador puede crear docentes, matricular estudiantes y vincular acudientes en su sede.</a:t>
             </a:r>
           </a:p>
         </p:txBody>
@@ -17277,7 +17350,7 @@
               </a:defRPr>
             </a:pPr>
             <a:r>
-              <a:t>Gobernanza Territorial: Integración DANE y DIVIPOLA</a:t>
+              <a:t>Gobernanza Territorial: Catálogo DANE/DIVIPOLA (DUE 2024)</a:t>
             </a:r>
           </a:p>
         </p:txBody>
@@ -17475,7 +17548,7 @@
               </a:defRPr>
             </a:pPr>
             <a:r>
-              <a:t>Estructura Territorial Oficial Colombiana</a:t>
+              <a:t>Catálogo Maestro de Referencia (DUE 2024)</a:t>
             </a:r>
           </a:p>
           <a:p>
@@ -17499,7 +17572,7 @@
             </a:r>
             <a:r>
               <a:rPr b="0"/>
-              <a:t> 32 departamentos y el Distrito Capital de Bogotá, identificados por código oficial de 2 dígitos.</a:t>
+              <a:t> 32 departamentos y Bogotá D.C., conforme a DIVIPOLA oficial.</a:t>
             </a:r>
           </a:p>
           <a:p>
@@ -17523,7 +17596,7 @@
             </a:r>
             <a:r>
               <a:rPr b="0"/>
-              <a:t> Catálogo nacional completo según codificación DIVIPOLA (5 dígitos).</a:t>
+              <a:t> Codificación DANE oficial (1,119 con cobertura de sedes en censo).</a:t>
             </a:r>
           </a:p>
           <a:p>
@@ -17547,31 +17620,31 @@
             </a:r>
             <a:r>
               <a:rPr b="0"/>
-              <a:t> Colegios oficiales y no oficiales precargados en base de datos con código DANE de 12 dígitos.</a:t>
-            </a:r>
-          </a:p>
-          <a:p>
-            <a:pPr>
-              <a:spcAft>
-                <a:spcPts val="600"/>
-              </a:spcAft>
-              <a:defRPr sz="1050">
-                <a:solidFill>
-                  <a:srgbClr val="1E293B"/>
-                </a:solidFill>
-              </a:defRPr>
-            </a:pPr>
-            <a:r>
-              <a:rPr b="1">
-                <a:solidFill>
-                  <a:srgbClr val="0F2942"/>
-                </a:solidFill>
-              </a:rPr>
-              <a:t>51,521 Sedes Educativas:</a:t>
+              <a:t> Cosechados de SODA cfw5-qzt5 (DUE 2024, 17,990 censados + 41 calibración).</a:t>
+            </a:r>
+          </a:p>
+          <a:p>
+            <a:pPr>
+              <a:spcAft>
+                <a:spcPts val="600"/>
+              </a:spcAft>
+              <a:defRPr sz="1050">
+                <a:solidFill>
+                  <a:srgbClr val="1E293B"/>
+                </a:solidFill>
+              </a:defRPr>
+            </a:pPr>
+            <a:r>
+              <a:rPr b="1">
+                <a:solidFill>
+                  <a:srgbClr val="0F2942"/>
+                </a:solidFill>
+              </a:rPr>
+              <a:t>51,521 Sedes Físicas Activas:</a:t>
             </a:r>
             <a:r>
               <a:rPr b="0"/>
-              <a:t> Cobertura de sedes principales y anexas (urbanas y rurales) estructuradas en el modelo relacional.</a:t>
+              <a:t> SODA 96t6-cfw4 (50,107 activas + 1,364 sedes principales + 50 semilla).</a:t>
             </a:r>
           </a:p>
         </p:txBody>
@@ -17654,31 +17727,31 @@
               </a:defRPr>
             </a:pPr>
             <a:r>
-              <a:t>Valor Estratégico para el MEN</a:t>
-            </a:r>
-          </a:p>
-          <a:p>
-            <a:pPr>
-              <a:spcAft>
-                <a:spcPts val="600"/>
-              </a:spcAft>
-              <a:defRPr sz="1050">
-                <a:solidFill>
-                  <a:srgbClr val="1E293B"/>
-                </a:solidFill>
-              </a:defRPr>
-            </a:pPr>
-            <a:r>
-              <a:rPr b="1">
-                <a:solidFill>
-                  <a:srgbClr val="0F2942"/>
-                </a:solidFill>
-              </a:rPr>
-              <a:t>Compatibilidad Inmediata:</a:t>
+              <a:t>Valor Estratégico y Aclaración de Adopción</a:t>
+            </a:r>
+          </a:p>
+          <a:p>
+            <a:pPr>
+              <a:spcAft>
+                <a:spcPts val="600"/>
+              </a:spcAft>
+              <a:defRPr sz="1050">
+                <a:solidFill>
+                  <a:srgbClr val="1E293B"/>
+                </a:solidFill>
+              </a:defRPr>
+            </a:pPr>
+            <a:r>
+              <a:rPr b="1">
+                <a:solidFill>
+                  <a:srgbClr val="0F2942"/>
+                </a:solidFill>
+              </a:rPr>
+              <a:t>Aprovisionamiento Instantáneo:</a:t>
             </a:r>
             <a:r>
               <a:rPr b="0"/>
-              <a:t> No requiere normalización previa de nombres de colegios o municipios; las llaves primarias ya coinciden con las del MEN.</a:t>
+              <a:t> Validación automática por código DANE de 12 dígitos sin migración manual.</a:t>
             </a:r>
           </a:p>
           <a:p>
@@ -17702,31 +17775,57 @@
             </a:r>
             <a:r>
               <a:rPr b="0"/>
-              <a:t> Capacidad de generar métricas agregadas por departamento, municipio o tipo de sector sin inconsistencias.</a:t>
-            </a:r>
-          </a:p>
-          <a:p>
-            <a:pPr>
-              <a:spcAft>
-                <a:spcPts val="600"/>
-              </a:spcAft>
-              <a:defRPr sz="1050">
-                <a:solidFill>
-                  <a:srgbClr val="1E293B"/>
-                </a:solidFill>
-              </a:defRPr>
-            </a:pPr>
-            <a:r>
-              <a:rPr b="1">
-                <a:solidFill>
-                  <a:srgbClr val="0F2942"/>
-                </a:solidFill>
-              </a:rPr>
-              <a:t>Aislamiento Territorial Forzado:</a:t>
+              <a:t> Agregación territorial limpia sin riesgo de duplicados o solapamientos.</a:t>
+            </a:r>
+          </a:p>
+          <a:p>
+            <a:pPr>
+              <a:spcAft>
+                <a:spcPts val="600"/>
+              </a:spcAft>
+              <a:defRPr sz="1050">
+                <a:solidFill>
+                  <a:srgbClr val="1E293B"/>
+                </a:solidFill>
+              </a:defRPr>
+            </a:pPr>
+            <a:r>
+              <a:rPr b="1">
+                <a:solidFill>
+                  <a:srgbClr val="0F2942"/>
+                </a:solidFill>
+              </a:rPr>
+              <a:t>Aclaración Institucional Mandatoria:</a:t>
             </a:r>
             <a:r>
               <a:rPr b="0"/>
-              <a:t> Las Secretarías de Educación Departamentales y Municipales solo pueden gestionar los colegios bajo su jurisdicción legal.</a:t>
+              <a:t> Las cifras anteriores corresponden al </a:t>
+            </a:r>
+            <a:r>
+              <a:rPr b="1">
+                <a:solidFill>
+                  <a:srgbClr val="0F2942"/>
+                </a:solidFill>
+              </a:rPr>
+              <a:t>catálogo de referencia precargado</a:t>
+            </a:r>
+            <a:r>
+              <a:rPr b="0"/>
+              <a:t> para habilitar la activación directiva.
+• </a:t>
+            </a:r>
+            <a:r>
+              <a:rPr b="1">
+                <a:solidFill>
+                  <a:srgbClr val="0F2942"/>
+                </a:solidFill>
+              </a:rPr>
+              <a:t>NO representan adopción operativa actual</a:t>
+            </a:r>
+            <a:r>
+              <a:rPr b="0"/>
+              <a:t> ni colegios en producción.
+• En la base operacional (`institutions`), existen actualmente 32 colegios de prueba/laboratorio (29 activos).</a:t>
             </a:r>
           </a:p>
         </p:txBody>

</xml_diff>

<commit_message>
Dictamen de Auditoría RBAC y Remediación de Accesos: Gestión Académica e Institucional
</commit_message>
<xml_diff>
--- a/docs/government/pdf/PEVN_PRESENTACION_INSTITUCIONAL_MEN.pptx
+++ b/docs/government/pdf/PEVN_PRESENTACION_INSTITUCIONAL_MEN.pptx
@@ -3312,10 +3312,6 @@
             </a:pPr>
             <a:r>
               <a:t>Autor / Iniciativa Técnica: Juan Carlos Castro Narváez | Versión: 1.0-FINAL-MEN | Octubre 2026</a:t>
-            </a:r>
-            <a:br/>
-            <a:r>
-              <a:t>Repositorio: github.com/juancastro2381-hub/Plataforma-Educativa-Virtual-Nacional-PEVN</a:t>
             </a:r>
             <a:br/>
             <a:r>
@@ -12919,15 +12915,6 @@
             <a:br/>
             <a:br/>
             <a:r>
-              <a:t>Repositorio Oficial del Proyecto:</a:t>
-            </a:r>
-            <a:br/>
-            <a:r>
-              <a:t>https://github.com/juancastro2381-hub/Plataforma-Educativa-Virtual-Nacional-PEVN.git</a:t>
-            </a:r>
-            <a:br/>
-            <a:br/>
-            <a:r>
               <a:t>Octubre 2026 — Bogotá D.C., Colombia</a:t>
             </a:r>
           </a:p>

</xml_diff>